<commit_message>
Update PowerPoint for song #148 in FUBC - Українські
</commit_message>
<xml_diff>
--- a/fubc-ua/148-За прекрасний світ чудес (Пісні Спасенних №145).pptx
+++ b/fubc-ua/148-За прекрасний світ чудес (Пісні Спасенних №145).pptx
@@ -775,7 +775,7 @@
           <a:p>
             <a:r>
               <a:rPr lang="en-US" dirty="0"/>
-              <a:t>P · 1/1</a:t>
+              <a:t>P · 1/1 · ||:1-1:||</a:t>
             </a:r>
             <a:endParaRPr lang="en-US" dirty="0"/>
           </a:p>
@@ -951,7 +951,7 @@
           <a:p>
             <a:r>
               <a:rPr lang="en-US" dirty="0"/>
-              <a:t>P · 1/1</a:t>
+              <a:t>P · 1/1 · ||:1-1:||</a:t>
             </a:r>
             <a:endParaRPr lang="en-US" dirty="0"/>
           </a:p>
@@ -1127,7 +1127,7 @@
           <a:p>
             <a:r>
               <a:rPr lang="en-US" dirty="0"/>
-              <a:t>P · 1/1</a:t>
+              <a:t>P · 1/1 · ||:1-1:||</a:t>
             </a:r>
             <a:endParaRPr lang="en-US" dirty="0"/>
           </a:p>
@@ -1303,7 +1303,7 @@
           <a:p>
             <a:r>
               <a:rPr lang="en-US" dirty="0"/>
-              <a:t>P · 1/1</a:t>
+              <a:t>P · 1/1 · ||:1-1:||</a:t>
             </a:r>
             <a:endParaRPr lang="en-US" dirty="0"/>
           </a:p>
@@ -1957,6 +1957,9 @@
           <a:lstStyle/>
           <a:p>
             <a:pPr algn="ctr" indent="0" marL="0">
+              <a:lnSpc>
+                <a:spcPts val="6200"/>
+              </a:lnSpc>
               <a:buNone/>
             </a:pPr>
             <a:r>
@@ -1968,12 +1971,15 @@
                 <a:ea typeface="Arial" pitchFamily="34" charset="-122"/>
                 <a:cs typeface="Arial" pitchFamily="34" charset="-120"/>
               </a:rPr>
-              <a:t>||: Отче, хвала Тобі! :||</a:t>
+              <a:t>Отче, хвала Тобі!</a:t>
             </a:r>
             <a:endParaRPr lang="en-US" sz="5200" dirty="0"/>
           </a:p>
           <a:p>
             <a:pPr algn="ctr" indent="0" marL="0">
+              <a:lnSpc>
+                <a:spcPts val="6200"/>
+              </a:lnSpc>
               <a:buNone/>
             </a:pPr>
             <a:r>
@@ -1988,6 +1994,91 @@
               <a:t>Отче Небесний, хвала Тобі!</a:t>
             </a:r>
             <a:endParaRPr lang="en-US" sz="5200" dirty="0"/>
+          </a:p>
+        </p:txBody>
+      </p:sp>
+      <p:sp>
+        <p:nvSpPr>
+          <p:cNvPr id="3" name="Shape 1"/>
+          <p:cNvSpPr/>
+          <p:nvPr/>
+        </p:nvSpPr>
+        <p:spPr>
+          <a:xfrm>
+            <a:off x="3025546" y="2755392"/>
+            <a:ext cx="0" cy="594360"/>
+          </a:xfrm>
+          <a:prstGeom prst="line">
+            <a:avLst/>
+          </a:prstGeom>
+          <a:noFill/>
+          <a:ln w="25400">
+            <a:solidFill>
+              <a:srgbClr val="8A8A8A"/>
+            </a:solidFill>
+            <a:prstDash val="solid"/>
+          </a:ln>
+        </p:spPr>
+      </p:sp>
+      <p:sp>
+        <p:nvSpPr>
+          <p:cNvPr id="4" name="Shape 2"/>
+          <p:cNvSpPr/>
+          <p:nvPr/>
+        </p:nvSpPr>
+        <p:spPr>
+          <a:xfrm>
+            <a:off x="9172550" y="2755392"/>
+            <a:ext cx="0" cy="594360"/>
+          </a:xfrm>
+          <a:prstGeom prst="line">
+            <a:avLst/>
+          </a:prstGeom>
+          <a:noFill/>
+          <a:ln w="25400">
+            <a:solidFill>
+              <a:srgbClr val="8A8A8A"/>
+            </a:solidFill>
+            <a:prstDash val="solid"/>
+          </a:ln>
+        </p:spPr>
+      </p:sp>
+      <p:sp>
+        <p:nvSpPr>
+          <p:cNvPr id="5" name="Text 3"/>
+          <p:cNvSpPr txBox="1"/>
+          <p:nvPr/>
+        </p:nvSpPr>
+        <p:spPr>
+          <a:xfrm>
+            <a:off x="9271610" y="2732532"/>
+            <a:ext cx="1097280" cy="640080"/>
+          </a:xfrm>
+          <a:prstGeom prst="rect">
+            <a:avLst/>
+          </a:prstGeom>
+          <a:noFill/>
+          <a:ln/>
+        </p:spPr>
+        <p:txBody>
+          <a:bodyPr wrap="square" lIns="0" tIns="0" rIns="0" bIns="0" rtlCol="0" anchor="ctr"/>
+          <a:lstStyle/>
+          <a:p>
+            <a:pPr algn="l" indent="0" marL="0">
+              <a:buNone/>
+            </a:pPr>
+            <a:r>
+              <a:rPr lang="en-US" sz="3600" b="1" dirty="0">
+                <a:solidFill>
+                  <a:srgbClr val="BBBBBB"/>
+                </a:solidFill>
+                <a:latin typeface="Arial" pitchFamily="34" charset="0"/>
+                <a:ea typeface="Arial" pitchFamily="34" charset="-122"/>
+                <a:cs typeface="Arial" pitchFamily="34" charset="-120"/>
+              </a:rPr>
+              <a:t>×2</a:t>
+            </a:r>
+            <a:endParaRPr lang="en-US" sz="3600" dirty="0"/>
           </a:p>
         </p:txBody>
       </p:sp>
@@ -2184,6 +2275,9 @@
           <a:lstStyle/>
           <a:p>
             <a:pPr algn="ctr" indent="0" marL="0">
+              <a:lnSpc>
+                <a:spcPts val="6200"/>
+              </a:lnSpc>
               <a:buNone/>
             </a:pPr>
             <a:r>
@@ -2195,12 +2289,15 @@
                 <a:ea typeface="Arial" pitchFamily="34" charset="-122"/>
                 <a:cs typeface="Arial" pitchFamily="34" charset="-120"/>
               </a:rPr>
-              <a:t>||: Отче, хвала Тобі! :||</a:t>
+              <a:t>Отче, хвала Тобі!</a:t>
             </a:r>
             <a:endParaRPr lang="en-US" sz="5200" dirty="0"/>
           </a:p>
           <a:p>
             <a:pPr algn="ctr" indent="0" marL="0">
+              <a:lnSpc>
+                <a:spcPts val="6200"/>
+              </a:lnSpc>
               <a:buNone/>
             </a:pPr>
             <a:r>
@@ -2215,6 +2312,91 @@
               <a:t>Отче Небесний, хвала Тобі!</a:t>
             </a:r>
             <a:endParaRPr lang="en-US" sz="5200" dirty="0"/>
+          </a:p>
+        </p:txBody>
+      </p:sp>
+      <p:sp>
+        <p:nvSpPr>
+          <p:cNvPr id="3" name="Shape 1"/>
+          <p:cNvSpPr/>
+          <p:nvPr/>
+        </p:nvSpPr>
+        <p:spPr>
+          <a:xfrm>
+            <a:off x="3025546" y="2755392"/>
+            <a:ext cx="0" cy="594360"/>
+          </a:xfrm>
+          <a:prstGeom prst="line">
+            <a:avLst/>
+          </a:prstGeom>
+          <a:noFill/>
+          <a:ln w="25400">
+            <a:solidFill>
+              <a:srgbClr val="8A8A8A"/>
+            </a:solidFill>
+            <a:prstDash val="solid"/>
+          </a:ln>
+        </p:spPr>
+      </p:sp>
+      <p:sp>
+        <p:nvSpPr>
+          <p:cNvPr id="4" name="Shape 2"/>
+          <p:cNvSpPr/>
+          <p:nvPr/>
+        </p:nvSpPr>
+        <p:spPr>
+          <a:xfrm>
+            <a:off x="9172550" y="2755392"/>
+            <a:ext cx="0" cy="594360"/>
+          </a:xfrm>
+          <a:prstGeom prst="line">
+            <a:avLst/>
+          </a:prstGeom>
+          <a:noFill/>
+          <a:ln w="25400">
+            <a:solidFill>
+              <a:srgbClr val="8A8A8A"/>
+            </a:solidFill>
+            <a:prstDash val="solid"/>
+          </a:ln>
+        </p:spPr>
+      </p:sp>
+      <p:sp>
+        <p:nvSpPr>
+          <p:cNvPr id="5" name="Text 3"/>
+          <p:cNvSpPr txBox="1"/>
+          <p:nvPr/>
+        </p:nvSpPr>
+        <p:spPr>
+          <a:xfrm>
+            <a:off x="9271610" y="2732532"/>
+            <a:ext cx="1097280" cy="640080"/>
+          </a:xfrm>
+          <a:prstGeom prst="rect">
+            <a:avLst/>
+          </a:prstGeom>
+          <a:noFill/>
+          <a:ln/>
+        </p:spPr>
+        <p:txBody>
+          <a:bodyPr wrap="square" lIns="0" tIns="0" rIns="0" bIns="0" rtlCol="0" anchor="ctr"/>
+          <a:lstStyle/>
+          <a:p>
+            <a:pPr algn="l" indent="0" marL="0">
+              <a:buNone/>
+            </a:pPr>
+            <a:r>
+              <a:rPr lang="en-US" sz="3600" b="1" dirty="0">
+                <a:solidFill>
+                  <a:srgbClr val="BBBBBB"/>
+                </a:solidFill>
+                <a:latin typeface="Arial" pitchFamily="34" charset="0"/>
+                <a:ea typeface="Arial" pitchFamily="34" charset="-122"/>
+                <a:cs typeface="Arial" pitchFamily="34" charset="-120"/>
+              </a:rPr>
+              <a:t>×2</a:t>
+            </a:r>
+            <a:endParaRPr lang="en-US" sz="3600" dirty="0"/>
           </a:p>
         </p:txBody>
       </p:sp>
@@ -2411,6 +2593,9 @@
           <a:lstStyle/>
           <a:p>
             <a:pPr algn="ctr" indent="0" marL="0">
+              <a:lnSpc>
+                <a:spcPts val="6200"/>
+              </a:lnSpc>
               <a:buNone/>
             </a:pPr>
             <a:r>
@@ -2422,12 +2607,15 @@
                 <a:ea typeface="Arial" pitchFamily="34" charset="-122"/>
                 <a:cs typeface="Arial" pitchFamily="34" charset="-120"/>
               </a:rPr>
-              <a:t>||: Отче, хвала Тобі! :||</a:t>
+              <a:t>Отче, хвала Тобі!</a:t>
             </a:r>
             <a:endParaRPr lang="en-US" sz="5200" dirty="0"/>
           </a:p>
           <a:p>
             <a:pPr algn="ctr" indent="0" marL="0">
+              <a:lnSpc>
+                <a:spcPts val="6200"/>
+              </a:lnSpc>
               <a:buNone/>
             </a:pPr>
             <a:r>
@@ -2442,6 +2630,91 @@
               <a:t>Отче Небесний, хвала Тобі!</a:t>
             </a:r>
             <a:endParaRPr lang="en-US" sz="5200" dirty="0"/>
+          </a:p>
+        </p:txBody>
+      </p:sp>
+      <p:sp>
+        <p:nvSpPr>
+          <p:cNvPr id="3" name="Shape 1"/>
+          <p:cNvSpPr/>
+          <p:nvPr/>
+        </p:nvSpPr>
+        <p:spPr>
+          <a:xfrm>
+            <a:off x="3025546" y="2755392"/>
+            <a:ext cx="0" cy="594360"/>
+          </a:xfrm>
+          <a:prstGeom prst="line">
+            <a:avLst/>
+          </a:prstGeom>
+          <a:noFill/>
+          <a:ln w="25400">
+            <a:solidFill>
+              <a:srgbClr val="8A8A8A"/>
+            </a:solidFill>
+            <a:prstDash val="solid"/>
+          </a:ln>
+        </p:spPr>
+      </p:sp>
+      <p:sp>
+        <p:nvSpPr>
+          <p:cNvPr id="4" name="Shape 2"/>
+          <p:cNvSpPr/>
+          <p:nvPr/>
+        </p:nvSpPr>
+        <p:spPr>
+          <a:xfrm>
+            <a:off x="9172550" y="2755392"/>
+            <a:ext cx="0" cy="594360"/>
+          </a:xfrm>
+          <a:prstGeom prst="line">
+            <a:avLst/>
+          </a:prstGeom>
+          <a:noFill/>
+          <a:ln w="25400">
+            <a:solidFill>
+              <a:srgbClr val="8A8A8A"/>
+            </a:solidFill>
+            <a:prstDash val="solid"/>
+          </a:ln>
+        </p:spPr>
+      </p:sp>
+      <p:sp>
+        <p:nvSpPr>
+          <p:cNvPr id="5" name="Text 3"/>
+          <p:cNvSpPr txBox="1"/>
+          <p:nvPr/>
+        </p:nvSpPr>
+        <p:spPr>
+          <a:xfrm>
+            <a:off x="9271610" y="2732532"/>
+            <a:ext cx="1097280" cy="640080"/>
+          </a:xfrm>
+          <a:prstGeom prst="rect">
+            <a:avLst/>
+          </a:prstGeom>
+          <a:noFill/>
+          <a:ln/>
+        </p:spPr>
+        <p:txBody>
+          <a:bodyPr wrap="square" lIns="0" tIns="0" rIns="0" bIns="0" rtlCol="0" anchor="ctr"/>
+          <a:lstStyle/>
+          <a:p>
+            <a:pPr algn="l" indent="0" marL="0">
+              <a:buNone/>
+            </a:pPr>
+            <a:r>
+              <a:rPr lang="en-US" sz="3600" b="1" dirty="0">
+                <a:solidFill>
+                  <a:srgbClr val="BBBBBB"/>
+                </a:solidFill>
+                <a:latin typeface="Arial" pitchFamily="34" charset="0"/>
+                <a:ea typeface="Arial" pitchFamily="34" charset="-122"/>
+                <a:cs typeface="Arial" pitchFamily="34" charset="-120"/>
+              </a:rPr>
+              <a:t>×2</a:t>
+            </a:r>
+            <a:endParaRPr lang="en-US" sz="3600" dirty="0"/>
           </a:p>
         </p:txBody>
       </p:sp>
@@ -2638,6 +2911,9 @@
           <a:lstStyle/>
           <a:p>
             <a:pPr algn="ctr" indent="0" marL="0">
+              <a:lnSpc>
+                <a:spcPts val="6200"/>
+              </a:lnSpc>
               <a:buNone/>
             </a:pPr>
             <a:r>
@@ -2649,12 +2925,15 @@
                 <a:ea typeface="Arial" pitchFamily="34" charset="-122"/>
                 <a:cs typeface="Arial" pitchFamily="34" charset="-120"/>
               </a:rPr>
-              <a:t>||: Отче, хвала Тобі! :||</a:t>
+              <a:t>Отче, хвала Тобі!</a:t>
             </a:r>
             <a:endParaRPr lang="en-US" sz="5200" dirty="0"/>
           </a:p>
           <a:p>
             <a:pPr algn="ctr" indent="0" marL="0">
+              <a:lnSpc>
+                <a:spcPts val="6200"/>
+              </a:lnSpc>
               <a:buNone/>
             </a:pPr>
             <a:r>
@@ -2674,7 +2953,92 @@
       </p:sp>
       <p:sp>
         <p:nvSpPr>
-          <p:cNvPr id="3" name="Text 1"/>
+          <p:cNvPr id="3" name="Shape 1"/>
+          <p:cNvSpPr/>
+          <p:nvPr/>
+        </p:nvSpPr>
+        <p:spPr>
+          <a:xfrm>
+            <a:off x="3025546" y="2755392"/>
+            <a:ext cx="0" cy="594360"/>
+          </a:xfrm>
+          <a:prstGeom prst="line">
+            <a:avLst/>
+          </a:prstGeom>
+          <a:noFill/>
+          <a:ln w="25400">
+            <a:solidFill>
+              <a:srgbClr val="8A8A8A"/>
+            </a:solidFill>
+            <a:prstDash val="solid"/>
+          </a:ln>
+        </p:spPr>
+      </p:sp>
+      <p:sp>
+        <p:nvSpPr>
+          <p:cNvPr id="4" name="Shape 2"/>
+          <p:cNvSpPr/>
+          <p:nvPr/>
+        </p:nvSpPr>
+        <p:spPr>
+          <a:xfrm>
+            <a:off x="9172550" y="2755392"/>
+            <a:ext cx="0" cy="594360"/>
+          </a:xfrm>
+          <a:prstGeom prst="line">
+            <a:avLst/>
+          </a:prstGeom>
+          <a:noFill/>
+          <a:ln w="25400">
+            <a:solidFill>
+              <a:srgbClr val="8A8A8A"/>
+            </a:solidFill>
+            <a:prstDash val="solid"/>
+          </a:ln>
+        </p:spPr>
+      </p:sp>
+      <p:sp>
+        <p:nvSpPr>
+          <p:cNvPr id="5" name="Text 3"/>
+          <p:cNvSpPr txBox="1"/>
+          <p:nvPr/>
+        </p:nvSpPr>
+        <p:spPr>
+          <a:xfrm>
+            <a:off x="9271610" y="2732532"/>
+            <a:ext cx="1097280" cy="640080"/>
+          </a:xfrm>
+          <a:prstGeom prst="rect">
+            <a:avLst/>
+          </a:prstGeom>
+          <a:noFill/>
+          <a:ln/>
+        </p:spPr>
+        <p:txBody>
+          <a:bodyPr wrap="square" lIns="0" tIns="0" rIns="0" bIns="0" rtlCol="0" anchor="ctr"/>
+          <a:lstStyle/>
+          <a:p>
+            <a:pPr algn="l" indent="0" marL="0">
+              <a:buNone/>
+            </a:pPr>
+            <a:r>
+              <a:rPr lang="en-US" sz="3600" b="1" dirty="0">
+                <a:solidFill>
+                  <a:srgbClr val="BBBBBB"/>
+                </a:solidFill>
+                <a:latin typeface="Arial" pitchFamily="34" charset="0"/>
+                <a:ea typeface="Arial" pitchFamily="34" charset="-122"/>
+                <a:cs typeface="Arial" pitchFamily="34" charset="-120"/>
+              </a:rPr>
+              <a:t>×2</a:t>
+            </a:r>
+            <a:endParaRPr lang="en-US" sz="3600" dirty="0"/>
+          </a:p>
+        </p:txBody>
+      </p:sp>
+      <p:sp>
+        <p:nvSpPr>
+          <p:cNvPr id="6" name="Text 4"/>
           <p:cNvSpPr txBox="1"/>
           <p:nvPr/>
         </p:nvSpPr>

</xml_diff>